<commit_message>
Runde 9: LF8 – Stadtstaat/Flaechenland-Slicer wieder aufgenommen; zwei Jahresfilter als notwendig bestaetigt
- Neuer Slicer dim_region[stadtstaat] (Mehrfachauswahl) rechts am Streudiagramm -> Confounder umschaltbar; live geprueft: Flaechenland gewaehlt -> 13 Punkte, Trendlinie kippt auf r<0; Auswahl geloescht -> alle 16
- Zwei Jahresfilter geprueft und bewusst behalten (NICHT redundant): X=fact_ausgaben_je_schueler[jahr]=2023 (Quelle 2010-2024, keine dim_zeit-Beziehung) + Y=fact_abgaenge[jahr]=2023 (2022/23); nur letztere haengt an dim_zeit -> nicht zu einem Filter konsolidierbar
- pbi_lf8.png neu gecroppt (mit Slicer); .pbix + bericht.pdf neu exportiert; DOCX/README/visual_spezifikation ergaenzt
- verify_all 110/110 (neuer LF8-Regressionsguard: Slicer + 2 Jahresfilter)

Co-Authored-By: Claude Fable 5 <noreply@anthropic.com>
</commit_message>
<xml_diff>
--- a/Schulabschluss_DataStory_Praesentation.pptx
+++ b/Schulabschluss_DataStory_Praesentation.pptx
@@ -4778,8 +4778,8 @@
         </p:blipFill>
         <p:spPr>
           <a:xfrm>
-            <a:off x="5989320" y="2083765"/>
-            <a:ext cx="5943600" cy="3879189"/>
+            <a:off x="5989320" y="2380413"/>
+            <a:ext cx="5943600" cy="3285892"/>
           </a:xfrm>
           <a:prstGeom prst="rect">
             <a:avLst/>

</xml_diff>